<commit_message>
Refresh marketplace claims and protect local Deck MCP writes
</commit_message>
<xml_diff>
--- a/decks/wetland-mcp-marketplace.pptx
+++ b/decks/wetland-mcp-marketplace.pptx
@@ -3892,7 +3892,7 @@
                 <a:ea typeface="Noto Sans Black"/>
                 <a:cs typeface="Noto Sans Black"/>
               </a:rPr>
-              <a:t>Find the helper. Paste the link. Then decide.</a:t>
+              <a:t>Find a capability. Open the approved agent.</a:t>
             </a:r>
           </a:p>
         </p:txBody>
@@ -3960,7 +3960,7 @@
                 <a:ea typeface="Noto Sans"/>
                 <a:cs typeface="Noto Sans"/>
               </a:rPr>
-              <a:t>Search by the task: a grant draft, a brand token, a retention question.</a:t>
+              <a:t>Browse Wetland by task and try the synthetic Growth demo.</a:t>
             </a:r>
           </a:p>
         </p:txBody>
@@ -4028,7 +4028,7 @@
                 <a:ea typeface="Noto Sans"/>
                 <a:cs typeface="Noto Sans"/>
               </a:rPr>
-              <a:t>Live and Pilot can be used. Proposed stays labelled as an idea.</a:t>
+              <a:t>Open the approved Copilot agent after IT configures its MCP connections.</a:t>
             </a:r>
           </a:p>
         </p:txBody>
@@ -4096,7 +4096,7 @@
                 <a:ea typeface="Noto Sans"/>
                 <a:cs typeface="Noto Sans"/>
               </a:rPr>
-              <a:t>Copy the MCP link into the assistant you already use. One helper per chat.</a:t>
+              <a:t>Copy the example prompt. Pasting an MCP URL alone does not connect Copilot.</a:t>
             </a:r>
           </a:p>
         </p:txBody>
@@ -4164,7 +4164,7 @@
                 <a:ea typeface="Noto Sans"/>
                 <a:cs typeface="Noto Sans"/>
               </a:rPr>
-              <a:t>Read the answer, open the source, and check it before it leaves your desk.</a:t>
+              <a:t>Review the report, source and definition before sharing.</a:t>
             </a:r>
           </a:p>
         </p:txBody>
@@ -4367,7 +4367,7 @@
                 <a:ea typeface="Noto Sans Black"/>
                 <a:cs typeface="Noto Sans Black"/>
               </a:rPr>
-              <a:t>One live endpoint. Seven honest concepts.</a:t>
+              <a:t>Brand and Growth are live demos</a:t>
             </a:r>
           </a:p>
         </p:txBody>
@@ -4585,13 +4585,193 @@
       </p:sp>
       <p:sp>
         <p:nvSpPr>
-          <p:cNvPr id="11" name="Rounded Rectangle 10"/>
+          <p:cNvPr id="11" name="Rectangle 10"/>
           <p:cNvSpPr/>
           <p:nvPr/>
         </p:nvSpPr>
         <p:spPr>
           <a:xfrm>
+            <a:off x="3495979" y="1947672"/>
+            <a:ext cx="64008" cy="1426464"/>
+          </a:xfrm>
+          <a:prstGeom prst="rect">
+            <a:avLst/>
+          </a:prstGeom>
+          <a:solidFill>
+            <a:srgbClr val="006BD9"/>
+          </a:solidFill>
+          <a:ln>
+            <a:noFill/>
+          </a:ln>
+        </p:spPr>
+        <p:txBody>
+          <a:bodyPr rtlCol="0" anchor="ctr"/>
+          <a:lstStyle/>
+          <a:p>
+            <a:pPr algn="ctr"/>
+          </a:p>
+        </p:txBody>
+      </p:sp>
+      <p:sp>
+        <p:nvSpPr>
+          <p:cNvPr id="12" name="Rounded Rectangle 11"/>
+          <p:cNvSpPr/>
+          <p:nvPr/>
+        </p:nvSpPr>
+        <p:spPr>
+          <a:xfrm>
             <a:off x="3569131" y="1874520"/>
+            <a:ext cx="1207008" cy="292608"/>
+          </a:xfrm>
+          <a:prstGeom prst="roundRect">
+            <a:avLst>
+              <a:gd name="adj" fmla="val 40000"/>
+            </a:avLst>
+          </a:prstGeom>
+          <a:solidFill>
+            <a:srgbClr val="D6FF00"/>
+          </a:solidFill>
+          <a:ln>
+            <a:noFill/>
+          </a:ln>
+        </p:spPr>
+        <p:txBody>
+          <a:bodyPr rtlCol="0" anchor="ctr" wrap="none"/>
+          <a:lstStyle/>
+          <a:p>
+            <a:pPr algn="ctr"/>
+            <a:r>
+              <a:rPr sz="1000" b="1">
+                <a:solidFill>
+                  <a:srgbClr val="151435"/>
+                </a:solidFill>
+                <a:latin typeface="Noto Sans"/>
+                <a:ea typeface="Noto Sans"/>
+                <a:cs typeface="Noto Sans"/>
+              </a:rPr>
+              <a:t>LIVE</a:t>
+            </a:r>
+          </a:p>
+        </p:txBody>
+      </p:sp>
+      <p:sp>
+        <p:nvSpPr>
+          <p:cNvPr id="13" name="TextBox 12"/>
+          <p:cNvSpPr txBox="1"/>
+          <p:nvPr/>
+        </p:nvSpPr>
+        <p:spPr>
+          <a:xfrm>
+            <a:off x="3569131" y="2313432"/>
+            <a:ext cx="2307259" cy="777240"/>
+          </a:xfrm>
+          <a:prstGeom prst="rect">
+            <a:avLst/>
+          </a:prstGeom>
+          <a:noFill/>
+        </p:spPr>
+        <p:txBody>
+          <a:bodyPr wrap="square" lIns="0" rIns="0" tIns="0" bIns="0" anchor="t"/>
+          <a:lstStyle/>
+          <a:p>
+            <a:pPr algn="l">
+              <a:lnSpc>
+                <a:spcPct val="95000"/>
+              </a:lnSpc>
+            </a:pPr>
+            <a:r>
+              <a:rPr sz="1500" b="0">
+                <a:solidFill>
+                  <a:srgbClr val="151435"/>
+                </a:solidFill>
+                <a:latin typeface="Noto Sans Black"/>
+                <a:ea typeface="Noto Sans Black"/>
+                <a:cs typeface="Noto Sans Black"/>
+              </a:rPr>
+              <a:t>Growth KPI reporting</a:t>
+            </a:r>
+          </a:p>
+        </p:txBody>
+      </p:sp>
+      <p:sp>
+        <p:nvSpPr>
+          <p:cNvPr id="14" name="TextBox 13"/>
+          <p:cNvSpPr txBox="1"/>
+          <p:nvPr/>
+        </p:nvSpPr>
+        <p:spPr>
+          <a:xfrm>
+            <a:off x="3569131" y="3136392"/>
+            <a:ext cx="2307259" cy="329184"/>
+          </a:xfrm>
+          <a:prstGeom prst="rect">
+            <a:avLst/>
+          </a:prstGeom>
+          <a:noFill/>
+        </p:spPr>
+        <p:txBody>
+          <a:bodyPr wrap="square" lIns="0" rIns="0" tIns="0" bIns="0" anchor="t"/>
+          <a:lstStyle/>
+          <a:p>
+            <a:pPr algn="l">
+              <a:lnSpc>
+                <a:spcPct val="100000"/>
+              </a:lnSpc>
+            </a:pPr>
+            <a:r>
+              <a:rPr sz="1100" b="0">
+                <a:solidFill>
+                  <a:srgbClr val="44435D"/>
+                </a:solidFill>
+                <a:latin typeface="Noto Sans"/>
+                <a:ea typeface="Noto Sans"/>
+                <a:cs typeface="Noto Sans"/>
+              </a:rPr>
+              <a:t>Synthetic donor reporting</a:t>
+            </a:r>
+          </a:p>
+        </p:txBody>
+      </p:sp>
+      <p:sp>
+        <p:nvSpPr>
+          <p:cNvPr id="15" name="Rounded Rectangle 14"/>
+          <p:cNvSpPr/>
+          <p:nvPr/>
+        </p:nvSpPr>
+        <p:spPr>
+          <a:xfrm>
+            <a:off x="6168999" y="1691640"/>
+            <a:ext cx="2654731" cy="1938528"/>
+          </a:xfrm>
+          <a:prstGeom prst="roundRect">
+            <a:avLst>
+              <a:gd name="adj" fmla="val 8000"/>
+            </a:avLst>
+          </a:prstGeom>
+          <a:solidFill>
+            <a:srgbClr val="FFFFFF"/>
+          </a:solidFill>
+          <a:ln>
+            <a:noFill/>
+          </a:ln>
+        </p:spPr>
+        <p:txBody>
+          <a:bodyPr rtlCol="0" anchor="ctr"/>
+          <a:lstStyle/>
+          <a:p>
+            <a:pPr algn="ctr"/>
+          </a:p>
+        </p:txBody>
+      </p:sp>
+      <p:sp>
+        <p:nvSpPr>
+          <p:cNvPr id="16" name="Rounded Rectangle 15"/>
+          <p:cNvSpPr/>
+          <p:nvPr/>
+        </p:nvSpPr>
+        <p:spPr>
+          <a:xfrm>
+            <a:off x="6370167" y="1874520"/>
             <a:ext cx="1207008" cy="292608"/>
           </a:xfrm>
           <a:prstGeom prst="roundRect">
@@ -4627,13 +4807,13 @@
       </p:sp>
       <p:sp>
         <p:nvSpPr>
-          <p:cNvPr id="12" name="TextBox 11"/>
+          <p:cNvPr id="17" name="TextBox 16"/>
           <p:cNvSpPr txBox="1"/>
           <p:nvPr/>
         </p:nvSpPr>
         <p:spPr>
           <a:xfrm>
-            <a:off x="3569131" y="2313432"/>
+            <a:off x="6370167" y="2313432"/>
             <a:ext cx="2307259" cy="777240"/>
           </a:xfrm>
           <a:prstGeom prst="rect">
@@ -4666,13 +4846,13 @@
       </p:sp>
       <p:sp>
         <p:nvSpPr>
-          <p:cNvPr id="13" name="TextBox 12"/>
+          <p:cNvPr id="18" name="TextBox 17"/>
           <p:cNvSpPr txBox="1"/>
           <p:nvPr/>
         </p:nvSpPr>
         <p:spPr>
           <a:xfrm>
-            <a:off x="3569131" y="3136392"/>
+            <a:off x="6370167" y="3136392"/>
             <a:ext cx="2307259" cy="329184"/>
           </a:xfrm>
           <a:prstGeom prst="rect">
@@ -4705,13 +4885,13 @@
       </p:sp>
       <p:sp>
         <p:nvSpPr>
-          <p:cNvPr id="14" name="Rounded Rectangle 13"/>
+          <p:cNvPr id="19" name="Rounded Rectangle 18"/>
           <p:cNvSpPr/>
           <p:nvPr/>
         </p:nvSpPr>
         <p:spPr>
           <a:xfrm>
-            <a:off x="6168999" y="1691640"/>
+            <a:off x="8970035" y="1691640"/>
             <a:ext cx="2654731" cy="1938528"/>
           </a:xfrm>
           <a:prstGeom prst="roundRect">
@@ -4736,13 +4916,13 @@
       </p:sp>
       <p:sp>
         <p:nvSpPr>
-          <p:cNvPr id="15" name="Rounded Rectangle 14"/>
+          <p:cNvPr id="20" name="Rounded Rectangle 19"/>
           <p:cNvSpPr/>
           <p:nvPr/>
         </p:nvSpPr>
         <p:spPr>
           <a:xfrm>
-            <a:off x="6370167" y="1874520"/>
+            <a:off x="9171203" y="1874520"/>
             <a:ext cx="1207008" cy="292608"/>
           </a:xfrm>
           <a:prstGeom prst="roundRect">
@@ -4778,13 +4958,13 @@
       </p:sp>
       <p:sp>
         <p:nvSpPr>
-          <p:cNvPr id="16" name="TextBox 15"/>
+          <p:cNvPr id="21" name="TextBox 20"/>
           <p:cNvSpPr txBox="1"/>
           <p:nvPr/>
         </p:nvSpPr>
         <p:spPr>
           <a:xfrm>
-            <a:off x="6370167" y="2313432"/>
+            <a:off x="9171203" y="2313432"/>
             <a:ext cx="2307259" cy="777240"/>
           </a:xfrm>
           <a:prstGeom prst="rect">
@@ -4817,13 +4997,13 @@
       </p:sp>
       <p:sp>
         <p:nvSpPr>
-          <p:cNvPr id="17" name="TextBox 16"/>
+          <p:cNvPr id="22" name="TextBox 21"/>
           <p:cNvSpPr txBox="1"/>
           <p:nvPr/>
         </p:nvSpPr>
         <p:spPr>
           <a:xfrm>
-            <a:off x="6370167" y="3136392"/>
+            <a:off x="9171203" y="3136392"/>
             <a:ext cx="2307259" cy="329184"/>
           </a:xfrm>
           <a:prstGeom prst="rect">
@@ -4856,13 +5036,13 @@
       </p:sp>
       <p:sp>
         <p:nvSpPr>
-          <p:cNvPr id="18" name="Rounded Rectangle 17"/>
+          <p:cNvPr id="23" name="Rounded Rectangle 22"/>
           <p:cNvSpPr/>
           <p:nvPr/>
         </p:nvSpPr>
         <p:spPr>
           <a:xfrm>
-            <a:off x="8970035" y="1691640"/>
+            <a:off x="566928" y="3776472"/>
             <a:ext cx="2654731" cy="1938528"/>
           </a:xfrm>
           <a:prstGeom prst="roundRect">
@@ -4887,13 +5067,13 @@
       </p:sp>
       <p:sp>
         <p:nvSpPr>
-          <p:cNvPr id="19" name="Rounded Rectangle 18"/>
+          <p:cNvPr id="24" name="Rounded Rectangle 23"/>
           <p:cNvSpPr/>
           <p:nvPr/>
         </p:nvSpPr>
         <p:spPr>
           <a:xfrm>
-            <a:off x="9171203" y="1874520"/>
+            <a:off x="768096" y="3959352"/>
             <a:ext cx="1207008" cy="292608"/>
           </a:xfrm>
           <a:prstGeom prst="roundRect">
@@ -4929,13 +5109,13 @@
       </p:sp>
       <p:sp>
         <p:nvSpPr>
-          <p:cNvPr id="20" name="TextBox 19"/>
+          <p:cNvPr id="25" name="TextBox 24"/>
           <p:cNvSpPr txBox="1"/>
           <p:nvPr/>
         </p:nvSpPr>
         <p:spPr>
           <a:xfrm>
-            <a:off x="9171203" y="2313432"/>
+            <a:off x="768096" y="4398264"/>
             <a:ext cx="2307259" cy="777240"/>
           </a:xfrm>
           <a:prstGeom prst="rect">
@@ -4968,13 +5148,13 @@
       </p:sp>
       <p:sp>
         <p:nvSpPr>
-          <p:cNvPr id="21" name="TextBox 20"/>
+          <p:cNvPr id="26" name="TextBox 25"/>
           <p:cNvSpPr txBox="1"/>
           <p:nvPr/>
         </p:nvSpPr>
         <p:spPr>
           <a:xfrm>
-            <a:off x="9171203" y="3136392"/>
+            <a:off x="768096" y="5221224"/>
             <a:ext cx="2307259" cy="329184"/>
           </a:xfrm>
           <a:prstGeom prst="rect">
@@ -5007,13 +5187,13 @@
       </p:sp>
       <p:sp>
         <p:nvSpPr>
-          <p:cNvPr id="22" name="Rounded Rectangle 21"/>
+          <p:cNvPr id="27" name="Rounded Rectangle 26"/>
           <p:cNvSpPr/>
           <p:nvPr/>
         </p:nvSpPr>
         <p:spPr>
           <a:xfrm>
-            <a:off x="566928" y="3776472"/>
+            <a:off x="3367963" y="3776472"/>
             <a:ext cx="2654731" cy="1938528"/>
           </a:xfrm>
           <a:prstGeom prst="roundRect">
@@ -5038,13 +5218,13 @@
       </p:sp>
       <p:sp>
         <p:nvSpPr>
-          <p:cNvPr id="23" name="Rounded Rectangle 22"/>
+          <p:cNvPr id="28" name="Rounded Rectangle 27"/>
           <p:cNvSpPr/>
           <p:nvPr/>
         </p:nvSpPr>
         <p:spPr>
           <a:xfrm>
-            <a:off x="768096" y="3959352"/>
+            <a:off x="3569131" y="3959352"/>
             <a:ext cx="1207008" cy="292608"/>
           </a:xfrm>
           <a:prstGeom prst="roundRect">
@@ -5080,13 +5260,13 @@
       </p:sp>
       <p:sp>
         <p:nvSpPr>
-          <p:cNvPr id="24" name="TextBox 23"/>
+          <p:cNvPr id="29" name="TextBox 28"/>
           <p:cNvSpPr txBox="1"/>
           <p:nvPr/>
         </p:nvSpPr>
         <p:spPr>
           <a:xfrm>
-            <a:off x="768096" y="4398264"/>
+            <a:off x="3569131" y="4398264"/>
             <a:ext cx="2307259" cy="777240"/>
           </a:xfrm>
           <a:prstGeom prst="rect">
@@ -5119,13 +5299,13 @@
       </p:sp>
       <p:sp>
         <p:nvSpPr>
-          <p:cNvPr id="25" name="TextBox 24"/>
+          <p:cNvPr id="30" name="TextBox 29"/>
           <p:cNvSpPr txBox="1"/>
           <p:nvPr/>
         </p:nvSpPr>
         <p:spPr>
           <a:xfrm>
-            <a:off x="768096" y="5221224"/>
+            <a:off x="3569131" y="5221224"/>
             <a:ext cx="2307259" cy="329184"/>
           </a:xfrm>
           <a:prstGeom prst="rect">
@@ -5158,13 +5338,13 @@
       </p:sp>
       <p:sp>
         <p:nvSpPr>
-          <p:cNvPr id="26" name="Rounded Rectangle 25"/>
+          <p:cNvPr id="31" name="Rounded Rectangle 30"/>
           <p:cNvSpPr/>
           <p:nvPr/>
         </p:nvSpPr>
         <p:spPr>
           <a:xfrm>
-            <a:off x="3367963" y="3776472"/>
+            <a:off x="6168999" y="3776472"/>
             <a:ext cx="2654731" cy="1938528"/>
           </a:xfrm>
           <a:prstGeom prst="roundRect">
@@ -5189,13 +5369,13 @@
       </p:sp>
       <p:sp>
         <p:nvSpPr>
-          <p:cNvPr id="27" name="Rounded Rectangle 26"/>
+          <p:cNvPr id="32" name="Rounded Rectangle 31"/>
           <p:cNvSpPr/>
           <p:nvPr/>
         </p:nvSpPr>
         <p:spPr>
           <a:xfrm>
-            <a:off x="3569131" y="3959352"/>
+            <a:off x="6370167" y="3959352"/>
             <a:ext cx="1207008" cy="292608"/>
           </a:xfrm>
           <a:prstGeom prst="roundRect">
@@ -5231,13 +5411,13 @@
       </p:sp>
       <p:sp>
         <p:nvSpPr>
-          <p:cNvPr id="28" name="TextBox 27"/>
+          <p:cNvPr id="33" name="TextBox 32"/>
           <p:cNvSpPr txBox="1"/>
           <p:nvPr/>
         </p:nvSpPr>
         <p:spPr>
           <a:xfrm>
-            <a:off x="3569131" y="4398264"/>
+            <a:off x="6370167" y="4398264"/>
             <a:ext cx="2307259" cy="777240"/>
           </a:xfrm>
           <a:prstGeom prst="rect">
@@ -5270,13 +5450,13 @@
       </p:sp>
       <p:sp>
         <p:nvSpPr>
-          <p:cNvPr id="29" name="TextBox 28"/>
+          <p:cNvPr id="34" name="TextBox 33"/>
           <p:cNvSpPr txBox="1"/>
           <p:nvPr/>
         </p:nvSpPr>
         <p:spPr>
           <a:xfrm>
-            <a:off x="3569131" y="5221224"/>
+            <a:off x="6370167" y="5221224"/>
             <a:ext cx="2307259" cy="329184"/>
           </a:xfrm>
           <a:prstGeom prst="rect">
@@ -5309,13 +5489,13 @@
       </p:sp>
       <p:sp>
         <p:nvSpPr>
-          <p:cNvPr id="30" name="Rounded Rectangle 29"/>
+          <p:cNvPr id="35" name="Rounded Rectangle 34"/>
           <p:cNvSpPr/>
           <p:nvPr/>
         </p:nvSpPr>
         <p:spPr>
           <a:xfrm>
-            <a:off x="6168999" y="3776472"/>
+            <a:off x="8970035" y="3776472"/>
             <a:ext cx="2654731" cy="1938528"/>
           </a:xfrm>
           <a:prstGeom prst="roundRect">
@@ -5340,13 +5520,13 @@
       </p:sp>
       <p:sp>
         <p:nvSpPr>
-          <p:cNvPr id="31" name="Rounded Rectangle 30"/>
+          <p:cNvPr id="36" name="Rounded Rectangle 35"/>
           <p:cNvSpPr/>
           <p:nvPr/>
         </p:nvSpPr>
         <p:spPr>
           <a:xfrm>
-            <a:off x="6370167" y="3959352"/>
+            <a:off x="9171203" y="3959352"/>
             <a:ext cx="1207008" cy="292608"/>
           </a:xfrm>
           <a:prstGeom prst="roundRect">
@@ -5382,13 +5562,13 @@
       </p:sp>
       <p:sp>
         <p:nvSpPr>
-          <p:cNvPr id="32" name="TextBox 31"/>
+          <p:cNvPr id="37" name="TextBox 36"/>
           <p:cNvSpPr txBox="1"/>
           <p:nvPr/>
         </p:nvSpPr>
         <p:spPr>
           <a:xfrm>
-            <a:off x="6370167" y="4398264"/>
+            <a:off x="9171203" y="4398264"/>
             <a:ext cx="2307259" cy="777240"/>
           </a:xfrm>
           <a:prstGeom prst="rect">
@@ -5421,13 +5601,13 @@
       </p:sp>
       <p:sp>
         <p:nvSpPr>
-          <p:cNvPr id="33" name="TextBox 32"/>
+          <p:cNvPr id="38" name="TextBox 37"/>
           <p:cNvSpPr txBox="1"/>
           <p:nvPr/>
         </p:nvSpPr>
         <p:spPr>
           <a:xfrm>
-            <a:off x="6370167" y="5221224"/>
+            <a:off x="9171203" y="5221224"/>
             <a:ext cx="2307259" cy="329184"/>
           </a:xfrm>
           <a:prstGeom prst="rect">
@@ -5460,126 +5640,14 @@
       </p:sp>
       <p:sp>
         <p:nvSpPr>
-          <p:cNvPr id="34" name="Rounded Rectangle 33"/>
-          <p:cNvSpPr/>
-          <p:nvPr/>
-        </p:nvSpPr>
-        <p:spPr>
-          <a:xfrm>
-            <a:off x="8970035" y="3776472"/>
-            <a:ext cx="2654731" cy="1938528"/>
-          </a:xfrm>
-          <a:prstGeom prst="roundRect">
-            <a:avLst>
-              <a:gd name="adj" fmla="val 8000"/>
-            </a:avLst>
-          </a:prstGeom>
-          <a:solidFill>
-            <a:srgbClr val="FFFFFF"/>
-          </a:solidFill>
-          <a:ln>
-            <a:noFill/>
-          </a:ln>
-        </p:spPr>
-        <p:txBody>
-          <a:bodyPr rtlCol="0" anchor="ctr"/>
-          <a:lstStyle/>
-          <a:p>
-            <a:pPr algn="ctr"/>
-          </a:p>
-        </p:txBody>
-      </p:sp>
-      <p:sp>
-        <p:nvSpPr>
-          <p:cNvPr id="35" name="Rounded Rectangle 34"/>
-          <p:cNvSpPr/>
-          <p:nvPr/>
-        </p:nvSpPr>
-        <p:spPr>
-          <a:xfrm>
-            <a:off x="9171203" y="3959352"/>
-            <a:ext cx="1207008" cy="292608"/>
-          </a:xfrm>
-          <a:prstGeom prst="roundRect">
-            <a:avLst>
-              <a:gd name="adj" fmla="val 40000"/>
-            </a:avLst>
-          </a:prstGeom>
-          <a:solidFill>
-            <a:srgbClr val="E7EEF6"/>
-          </a:solidFill>
-          <a:ln>
-            <a:noFill/>
-          </a:ln>
-        </p:spPr>
-        <p:txBody>
-          <a:bodyPr rtlCol="0" anchor="ctr" wrap="none"/>
-          <a:lstStyle/>
-          <a:p>
-            <a:pPr algn="ctr"/>
-            <a:r>
-              <a:rPr sz="1000" b="1">
-                <a:solidFill>
-                  <a:srgbClr val="44435D"/>
-                </a:solidFill>
-                <a:latin typeface="Noto Sans"/>
-                <a:ea typeface="Noto Sans"/>
-                <a:cs typeface="Noto Sans"/>
-              </a:rPr>
-              <a:t>CONCEPT</a:t>
-            </a:r>
-          </a:p>
-        </p:txBody>
-      </p:sp>
-      <p:sp>
-        <p:nvSpPr>
-          <p:cNvPr id="36" name="TextBox 35"/>
+          <p:cNvPr id="39" name="TextBox 38"/>
           <p:cNvSpPr txBox="1"/>
           <p:nvPr/>
         </p:nvSpPr>
         <p:spPr>
           <a:xfrm>
-            <a:off x="9171203" y="4398264"/>
-            <a:ext cx="2307259" cy="777240"/>
-          </a:xfrm>
-          <a:prstGeom prst="rect">
-            <a:avLst/>
-          </a:prstGeom>
-          <a:noFill/>
-        </p:spPr>
-        <p:txBody>
-          <a:bodyPr wrap="square" lIns="0" rIns="0" tIns="0" bIns="0" anchor="t"/>
-          <a:lstStyle/>
-          <a:p>
-            <a:pPr algn="l">
-              <a:lnSpc>
-                <a:spcPct val="95000"/>
-              </a:lnSpc>
-            </a:pPr>
-            <a:r>
-              <a:rPr sz="1500" b="0">
-                <a:solidFill>
-                  <a:srgbClr val="151435"/>
-                </a:solidFill>
-                <a:latin typeface="Noto Sans Black"/>
-                <a:ea typeface="Noto Sans Black"/>
-                <a:cs typeface="Noto Sans Black"/>
-              </a:rPr>
-              <a:t>Team knowledge</a:t>
-            </a:r>
-          </a:p>
-        </p:txBody>
-      </p:sp>
-      <p:sp>
-        <p:nvSpPr>
-          <p:cNvPr id="37" name="TextBox 36"/>
-          <p:cNvSpPr txBox="1"/>
-          <p:nvPr/>
-        </p:nvSpPr>
-        <p:spPr>
-          <a:xfrm>
-            <a:off x="9171203" y="5221224"/>
-            <a:ext cx="2307259" cy="329184"/>
+            <a:off x="566928" y="6446520"/>
+            <a:ext cx="8778240" cy="256032"/>
           </a:xfrm>
           <a:prstGeom prst="rect">
             <a:avLst/>
@@ -5604,45 +5672,6 @@
                 <a:ea typeface="Noto Sans"/>
                 <a:cs typeface="Noto Sans"/>
               </a:rPr>
-              <a:t>IT &amp; Operations</a:t>
-            </a:r>
-          </a:p>
-        </p:txBody>
-      </p:sp>
-      <p:sp>
-        <p:nvSpPr>
-          <p:cNvPr id="38" name="TextBox 37"/>
-          <p:cNvSpPr txBox="1"/>
-          <p:nvPr/>
-        </p:nvSpPr>
-        <p:spPr>
-          <a:xfrm>
-            <a:off x="566928" y="6446520"/>
-            <a:ext cx="8778240" cy="256032"/>
-          </a:xfrm>
-          <a:prstGeom prst="rect">
-            <a:avLst/>
-          </a:prstGeom>
-          <a:noFill/>
-        </p:spPr>
-        <p:txBody>
-          <a:bodyPr wrap="square" lIns="0" rIns="0" tIns="0" bIns="0" anchor="t"/>
-          <a:lstStyle/>
-          <a:p>
-            <a:pPr algn="l">
-              <a:lnSpc>
-                <a:spcPct val="100000"/>
-              </a:lnSpc>
-            </a:pPr>
-            <a:r>
-              <a:rPr sz="1100" b="0">
-                <a:solidFill>
-                  <a:srgbClr val="44435D"/>
-                </a:solidFill>
-                <a:latin typeface="Noto Sans"/>
-                <a:ea typeface="Noto Sans"/>
-                <a:cs typeface="Noto Sans"/>
-              </a:rPr>
               <a:t>Independent Wetland project  ·  Not official WaterAid guidance</a:t>
             </a:r>
           </a:p>
@@ -5650,7 +5679,7 @@
       </p:sp>
       <p:sp>
         <p:nvSpPr>
-          <p:cNvPr id="39" name="TextBox 38"/>
+          <p:cNvPr id="40" name="TextBox 39"/>
           <p:cNvSpPr txBox="1"/>
           <p:nvPr/>
         </p:nvSpPr>
@@ -5904,7 +5933,7 @@
                 <a:ea typeface="Noto Sans"/>
                 <a:cs typeface="Noto Sans"/>
               </a:rPr>
-              <a:t>An agent sends a brief: the message, the points, and the layout.</a:t>
+              <a:t>An agent sends a brief to the locally run Deck MCP.</a:t>
             </a:r>
           </a:p>
         </p:txBody>
@@ -6517,7 +6546,7 @@
                 <a:ea typeface="Noto Sans"/>
                 <a:cs typeface="Noto Sans"/>
               </a:rPr>
-              <a:t>The story is the Wetland marketplace: status, owner, and a link you can paste.</a:t>
+              <a:t>Find capabilities, demo links and connection instructions in Wetland.</a:t>
             </a:r>
           </a:p>
         </p:txBody>
@@ -7659,7 +7688,7 @@
                 <a:ea typeface="Noto Sans"/>
                 <a:cs typeface="Noto Sans"/>
               </a:rPr>
-              <a:t>The marketplace is the front door. The Deck MCP is how a presentation comes back out.</a:t>
+              <a:t>Try Growth and Brand live. Deck generation runs locally; a published Copilot agent still requires tenant setup.</a:t>
             </a:r>
           </a:p>
         </p:txBody>

</xml_diff>